<commit_message>
Verify MongoDB demo workflow and align course report
</commit_message>
<xml_diff>
--- a/presentations/VaultX_MongoDB_Class_Presentation.pptx
+++ b/presentations/VaultX_MongoDB_Class_Presentation.pptx
@@ -2,24 +2,24 @@
 <file path=ppt/presentation.xml><?xml version="1.0" encoding="utf-8"?>
 <p:presentation xmlns:p="http://schemas.openxmlformats.org/presentationml/2006/main">
   <p:sldMasterIdLst>
-    <p:sldMasterId xmlns:r="http://schemas.openxmlformats.org/officeDocument/2006/relationships" id="2147483648" r:id="R78740dd75f394610"/>
+    <p:sldMasterId xmlns:r="http://schemas.openxmlformats.org/officeDocument/2006/relationships" id="2147483648" r:id="Rb37a5918f0c9405c"/>
   </p:sldMasterIdLst>
   <p:notesMasterIdLst>
-    <p:notesMasterId xmlns:r="http://schemas.openxmlformats.org/officeDocument/2006/relationships" r:id="R24463dc44a4f4516"/>
+    <p:notesMasterId xmlns:r="http://schemas.openxmlformats.org/officeDocument/2006/relationships" r:id="R2c86d5d9d1ea4a69"/>
   </p:notesMasterIdLst>
   <p:sldIdLst>
-    <p:sldId xmlns:r="http://schemas.openxmlformats.org/officeDocument/2006/relationships" id="256" r:id="R2c66a643d58249dd"/>
-    <p:sldId xmlns:r="http://schemas.openxmlformats.org/officeDocument/2006/relationships" id="257" r:id="R6bd35c59ece94066"/>
-    <p:sldId xmlns:r="http://schemas.openxmlformats.org/officeDocument/2006/relationships" id="258" r:id="R5f5de99307614a15"/>
-    <p:sldId xmlns:r="http://schemas.openxmlformats.org/officeDocument/2006/relationships" id="259" r:id="R0661eee1feda4c73"/>
-    <p:sldId xmlns:r="http://schemas.openxmlformats.org/officeDocument/2006/relationships" id="260" r:id="R806ff60897c24535"/>
-    <p:sldId xmlns:r="http://schemas.openxmlformats.org/officeDocument/2006/relationships" id="261" r:id="R1f8001c6718840ff"/>
-    <p:sldId xmlns:r="http://schemas.openxmlformats.org/officeDocument/2006/relationships" id="262" r:id="Ra1caacbd88464619"/>
-    <p:sldId xmlns:r="http://schemas.openxmlformats.org/officeDocument/2006/relationships" id="263" r:id="R07d2f314688b40b1"/>
-    <p:sldId xmlns:r="http://schemas.openxmlformats.org/officeDocument/2006/relationships" id="264" r:id="Rac9c776d516f48b4"/>
-    <p:sldId xmlns:r="http://schemas.openxmlformats.org/officeDocument/2006/relationships" id="265" r:id="R14d37998f7d44dfb"/>
-    <p:sldId xmlns:r="http://schemas.openxmlformats.org/officeDocument/2006/relationships" id="266" r:id="R5d708630e91542ed"/>
-    <p:sldId xmlns:r="http://schemas.openxmlformats.org/officeDocument/2006/relationships" id="267" r:id="R4145828648534e52"/>
+    <p:sldId xmlns:r="http://schemas.openxmlformats.org/officeDocument/2006/relationships" id="256" r:id="R07f745ed3ef04ecc"/>
+    <p:sldId xmlns:r="http://schemas.openxmlformats.org/officeDocument/2006/relationships" id="257" r:id="R5cb746a829c74ad3"/>
+    <p:sldId xmlns:r="http://schemas.openxmlformats.org/officeDocument/2006/relationships" id="258" r:id="Rdd60034e454545a4"/>
+    <p:sldId xmlns:r="http://schemas.openxmlformats.org/officeDocument/2006/relationships" id="259" r:id="R79d68f1a32674cb1"/>
+    <p:sldId xmlns:r="http://schemas.openxmlformats.org/officeDocument/2006/relationships" id="260" r:id="R1e89e6ab6a0e4b20"/>
+    <p:sldId xmlns:r="http://schemas.openxmlformats.org/officeDocument/2006/relationships" id="261" r:id="Re8c186f0ba9d4cae"/>
+    <p:sldId xmlns:r="http://schemas.openxmlformats.org/officeDocument/2006/relationships" id="262" r:id="R5aa4afaf44474979"/>
+    <p:sldId xmlns:r="http://schemas.openxmlformats.org/officeDocument/2006/relationships" id="263" r:id="R0528b59c18ed4f62"/>
+    <p:sldId xmlns:r="http://schemas.openxmlformats.org/officeDocument/2006/relationships" id="264" r:id="R8011afa323e0489c"/>
+    <p:sldId xmlns:r="http://schemas.openxmlformats.org/officeDocument/2006/relationships" id="265" r:id="R069c3b99fe524693"/>
+    <p:sldId xmlns:r="http://schemas.openxmlformats.org/officeDocument/2006/relationships" id="266" r:id="R41820771006944b5"/>
+    <p:sldId xmlns:r="http://schemas.openxmlformats.org/officeDocument/2006/relationships" id="267" r:id="R1e73ff04d9eb49b0"/>
   </p:sldIdLst>
   <p:sldSz cx="12192000" cy="6858000"/>
   <p:notesSz cx="6858000" cy="9144000"/>
@@ -593,7 +593,7 @@
           <a:lstStyle xmlns:a="http://schemas.openxmlformats.org/drawingml/2006/main"/>
           <a:p xmlns:a="http://schemas.openxmlformats.org/drawingml/2006/main">
             <a:r>
-              <a:t>Live connection check dated 18 October 2026: Atlas had 15 file records, 10 usable for ML, 9 small and 1 large. The local database had no file records. Minimum for training is 40 usable records and 5 in each class. Source: reports/MONGODB_PROJECT_REPORT.md and analytics/results/metrics.json in the project repository. Synthetic demo results were generated with seed 42.</a:t>
+              <a:t>Live connection check on 29 October 2026: Atlas had 16 file records, 11 usable for ML, 10 small and 1 large. Local MongoDB had no file records. Minimum for real training is 40 usable records and 5 in each class. The 600-record synthetic demo was seeded and evaluated through PyMongo against Atlas.</a:t>
             </a:r>
           </a:p>
         </p:txBody>
@@ -3666,12 +3666,12 @@
   </p:cSld>
   <p:clrMap bg1="lt1" tx1="dk1" bg2="lt2" tx2="dk2" accent1="accent1" accent2="accent2" accent3="accent3" accent4="accent4" accent5="accent5" accent6="accent6" hlink="hlink" folHlink="folHlink"/>
   <p:sldLayoutIdLst>
-    <p:sldLayoutId xmlns:r="http://schemas.openxmlformats.org/officeDocument/2006/relationships" id="2147483649" r:id="R15e62cfc67e740a2"/>
-    <p:sldLayoutId xmlns:r="http://schemas.openxmlformats.org/officeDocument/2006/relationships" id="2147483650" r:id="Raabd8c6def5045f5"/>
-    <p:sldLayoutId xmlns:r="http://schemas.openxmlformats.org/officeDocument/2006/relationships" id="2147483651" r:id="Rfce583609ba744e0"/>
-    <p:sldLayoutId xmlns:r="http://schemas.openxmlformats.org/officeDocument/2006/relationships" id="2147483652" r:id="Rae5c6ac08a284b83"/>
-    <p:sldLayoutId xmlns:r="http://schemas.openxmlformats.org/officeDocument/2006/relationships" id="2147483653" r:id="R5da5c4463766475c"/>
-    <p:sldLayoutId xmlns:r="http://schemas.openxmlformats.org/officeDocument/2006/relationships" id="2147483654" r:id="R63aa3549b5a64729"/>
+    <p:sldLayoutId xmlns:r="http://schemas.openxmlformats.org/officeDocument/2006/relationships" id="2147483649" r:id="R74311d8ee12646e0"/>
+    <p:sldLayoutId xmlns:r="http://schemas.openxmlformats.org/officeDocument/2006/relationships" id="2147483650" r:id="R1aea5f8adb8b4a23"/>
+    <p:sldLayoutId xmlns:r="http://schemas.openxmlformats.org/officeDocument/2006/relationships" id="2147483651" r:id="R34199d925b2a4d3f"/>
+    <p:sldLayoutId xmlns:r="http://schemas.openxmlformats.org/officeDocument/2006/relationships" id="2147483652" r:id="Rdb5d1525eb8d4740"/>
+    <p:sldLayoutId xmlns:r="http://schemas.openxmlformats.org/officeDocument/2006/relationships" id="2147483653" r:id="Re9e3de7fd331400b"/>
+    <p:sldLayoutId xmlns:r="http://schemas.openxmlformats.org/officeDocument/2006/relationships" id="2147483654" r:id="R420758d42b0b4165"/>
   </p:sldLayoutIdLst>
   <p:txStyles>
     <p:titleStyle>
@@ -5034,7 +5034,7 @@
           <p:nvPr/>
         </p:nvPicPr>
         <p:blipFill>
-          <a:blip xmlns:r="http://schemas.openxmlformats.org/officeDocument/2006/relationships" xmlns:a="http://schemas.openxmlformats.org/drawingml/2006/main" r:embed="R5fd890c9dee044dd"/>
+          <a:blip xmlns:r="http://schemas.openxmlformats.org/officeDocument/2006/relationships" xmlns:a="http://schemas.openxmlformats.org/drawingml/2006/main" r:embed="Re2aa94d6eb8f410e"/>
           <a:stretch xmlns:a="http://schemas.openxmlformats.org/drawingml/2006/main"/>
         </p:blipFill>
         <p:spPr>
@@ -5609,7 +5609,7 @@
         </p:xfrm>
         <a:graphic xmlns:a="http://schemas.openxmlformats.org/drawingml/2006/main">
           <a:graphicData uri="http://schemas.openxmlformats.org/drawingml/2006/chart">
-            <c:chart xmlns:r="http://schemas.openxmlformats.org/officeDocument/2006/relationships" xmlns:c="http://schemas.openxmlformats.org/drawingml/2006/chart" r:id="Rd2d643d20e024bde"/>
+            <c:chart xmlns:r="http://schemas.openxmlformats.org/officeDocument/2006/relationships" xmlns:c="http://schemas.openxmlformats.org/drawingml/2006/chart" r:id="R463a7152410c49cb"/>
           </a:graphicData>
         </a:graphic>
       </p:graphicFrame>
@@ -6667,7 +6667,7 @@
                   <a:srgbClr val="1D2B38"/>
                 </a:solidFill>
               </a:rPr>
-              <a:t>Performance on real vault data. On 18 October 2026, the live check found 10 usable file records, with one at least 5 MB. That is below the training threshold.</a:t>
+              <a:t>Performance on real vault data. On 29 October 2026, Atlas had 11 usable file records, with one at least 5 MB. That is below the training threshold.</a:t>
             </a:r>
           </a:p>
         </p:txBody>
@@ -13945,7 +13945,7 @@
                   <a:srgbClr val="112E4D"/>
                 </a:solidFill>
               </a:rPr>
-              <a:t>The demo collection stays separate from user files</a:t>
+              <a:t>The demo collection is separate from user files</a:t>
             </a:r>
           </a:p>
         </p:txBody>
@@ -14066,7 +14066,7 @@
                   <a:srgbClr val="1D2B38"/>
                 </a:solidFill>
               </a:rPr>
-              <a:t>Records can be upserted into ml_demo_files. The generated-only run produces the same data without connecting to MongoDB.</a:t>
+              <a:t>On 29 October, 600 synthetic records were added to ml_demo_files in Atlas. An offline run reproduced the same scores.</a:t>
             </a:r>
           </a:p>
         </p:txBody>

</xml_diff>